<commit_message>
Add demo video link, video script and final deck
- Demo video link on slide 14, in README and in the submission checklist
- 4-speaker video script (md, pdf, docx)
- AI usage log wording aligned with the signed disclosure form
</commit_message>
<xml_diff>
--- a/SRM_Univ_Fantastic_4_Submission.pptx
+++ b/SRM_Univ_Fantastic_4_Submission.pptx
@@ -1994,7 +1994,7 @@
           <a:lstStyle/>
           <a:p>
             <a:r>
-              <a:t>Demo video is not recorded yet: replace the placeholder with the YouTube or Drive link before submitting. Docker was verified on one development machine only.</a:t>
+              <a:t>All items complete. Demo video: https://drive.google.com/file/d/1qTrza9E9xEB6LtJP4BIdPNYOMkvRrxV3/view?usp=sharing. Docker was verified on one development machine only.</a:t>
             </a:r>
           </a:p>
         </p:txBody>
@@ -15670,7 +15670,7 @@
             </a:avLst>
           </a:prstGeom>
           <a:solidFill>
-            <a:srgbClr val="FDF1DC"/>
+            <a:srgbClr val="E6F4EC"/>
           </a:solidFill>
           <a:ln>
             <a:noFill/>
@@ -15686,11 +15686,11 @@
             <a:r>
               <a:rPr sz="1100" b="1" i="0">
                 <a:solidFill>
-                  <a:srgbClr val="B45309"/>
-                </a:solidFill>
-                <a:latin typeface="Calibri"/>
-              </a:rPr>
-              <a:t>PENDING</a:t>
+                  <a:srgbClr val="15803D"/>
+                </a:solidFill>
+                <a:latin typeface="Calibri"/>
+              </a:rPr>
+              <a:t>Y</a:t>
             </a:r>
           </a:p>
         </p:txBody>
@@ -15741,11 +15741,12 @@
             <a:r>
               <a:rPr sz="1150" b="1" i="0">
                 <a:solidFill>
-                  <a:srgbClr val="B45309"/>
-                </a:solidFill>
-                <a:latin typeface="Calibri"/>
-              </a:rPr>
-              <a:t>[ DEMO VIDEO LINK — TO BE ADDED BY THE TEAM ]</a:t>
+                  <a:srgbClr val="6D28D9"/>
+                </a:solidFill>
+                <a:latin typeface="Calibri"/>
+                <a:hlinkClick r:id="rId4"/>
+              </a:rPr>
+              <a:t>https://drive.google.com/file/d/1qTrza9E9xEB6LtJP4BIdPNYOMkvRrxV3/view?usp=sharing</a:t>
             </a:r>
           </a:p>
         </p:txBody>

</xml_diff>